<commit_message>
fix(sesi-02): sempurnakan validitas svg xml, lengkapi diagram mermaid 18 slide, dan detailkan konten slide 01 pptx
</commit_message>
<xml_diff>
--- a/slide_presentasi/SESI_02_Frontend_Modern_Vue.pptx
+++ b/slide_presentasi/SESI_02_Frontend_Modern_Vue.pptx
@@ -3156,8 +3156,8 @@
         </p:nvSpPr>
         <p:spPr>
           <a:xfrm>
-            <a:off x="896112" y="896112"/>
-            <a:ext cx="10545775" cy="5212080"/>
+            <a:off x="896112" y="530352"/>
+            <a:ext cx="10545775" cy="5897880"/>
           </a:xfrm>
           <a:prstGeom prst="rect">
             <a:avLst/>
@@ -3199,8 +3199,8 @@
         </p:nvSpPr>
         <p:spPr>
           <a:xfrm>
-            <a:off x="822960" y="822960"/>
-            <a:ext cx="10545775" cy="5212080"/>
+            <a:off x="822960" y="457200"/>
+            <a:ext cx="10545775" cy="5897880"/>
           </a:xfrm>
           <a:prstGeom prst="rect">
             <a:avLst/>
@@ -3244,8 +3244,8 @@
         </p:nvSpPr>
         <p:spPr>
           <a:xfrm>
-            <a:off x="1280160" y="1097280"/>
-            <a:ext cx="9601200" cy="3931920"/>
+            <a:off x="1097280" y="594360"/>
+            <a:ext cx="9997135" cy="1371600"/>
           </a:xfrm>
           <a:prstGeom prst="rect">
             <a:avLst/>
@@ -3260,9 +3260,9 @@
           <a:p>
             <a:pPr>
               <a:spcAft>
-                <a:spcPts val="1200"/>
+                <a:spcPts val="400"/>
               </a:spcAft>
-              <a:defRPr sz="1200" b="1">
+              <a:defRPr sz="1100" b="1">
                 <a:solidFill>
                   <a:srgbClr val="000000"/>
                 </a:solidFill>
@@ -3276,9 +3276,9 @@
           <a:p>
             <a:pPr>
               <a:spcAft>
-                <a:spcPts val="1000"/>
+                <a:spcPts val="400"/>
               </a:spcAft>
-              <a:defRPr sz="2600" b="1">
+              <a:defRPr sz="2300" b="1">
                 <a:solidFill>
                   <a:srgbClr val="000000"/>
                 </a:solidFill>
@@ -3291,12 +3291,9 @@
           </a:p>
           <a:p>
             <a:pPr>
-              <a:spcAft>
-                <a:spcPts val="1800"/>
-              </a:spcAft>
-              <a:defRPr sz="1300">
-                <a:solidFill>
-                  <a:srgbClr val="3C3C3C"/>
+              <a:defRPr sz="1100">
+                <a:solidFill>
+                  <a:srgbClr val="464646"/>
                 </a:solidFill>
                 <a:latin typeface="Segoe UI"/>
               </a:defRPr>
@@ -3307,19 +3304,6 @@
             <a:br/>
             <a:r>
               <a:t>Modul Acuan BMP: Modul 2 • Reaktivitas, Direktif Template, Lifecycle, &amp; Modular Components</a:t>
-            </a:r>
-          </a:p>
-          <a:p>
-            <a:pPr>
-              <a:defRPr sz="1100" b="1">
-                <a:solidFill>
-                  <a:srgbClr val="000000"/>
-                </a:solidFill>
-                <a:latin typeface="Segoe UI"/>
-              </a:defRPr>
-            </a:pPr>
-            <a:r>
-              <a:t>■  Anton Prafanto, S.Kom., M.T.  ■  FAKULTAS SAINS DAN TEKNOLOGI • UNIVERSITAS TERBUKA</a:t>
             </a:r>
           </a:p>
         </p:txBody>
@@ -3332,8 +3316,8 @@
         </p:nvSpPr>
         <p:spPr>
           <a:xfrm>
-            <a:off x="1316736" y="5111496"/>
-            <a:ext cx="9601200" cy="621792"/>
+            <a:off x="1170432" y="2130552"/>
+            <a:ext cx="4864608" cy="2468880"/>
           </a:xfrm>
           <a:prstGeom prst="rect">
             <a:avLst/>
@@ -3369,7 +3353,497 @@
       </p:sp>
       <p:sp>
         <p:nvSpPr>
-          <p:cNvPr id="7" name="Rectangle 6">
+          <p:cNvPr id="7" name="Rectangle 6"/>
+          <p:cNvSpPr/>
+          <p:nvPr/>
+        </p:nvSpPr>
+        <p:spPr>
+          <a:xfrm>
+            <a:off x="1097280" y="2057400"/>
+            <a:ext cx="4864608" cy="2468880"/>
+          </a:xfrm>
+          <a:prstGeom prst="rect">
+            <a:avLst/>
+          </a:prstGeom>
+          <a:solidFill>
+            <a:srgbClr val="FEF2F2"/>
+          </a:solidFill>
+          <a:ln w="31750">
+            <a:solidFill>
+              <a:srgbClr val="000000"/>
+            </a:solidFill>
+          </a:ln>
+        </p:spPr>
+        <p:style>
+          <a:lnRef idx="1">
+            <a:schemeClr val="accent1"/>
+          </a:lnRef>
+          <a:fillRef idx="3">
+            <a:schemeClr val="accent1"/>
+          </a:fillRef>
+          <a:effectRef idx="2">
+            <a:schemeClr val="accent1"/>
+          </a:effectRef>
+          <a:fontRef idx="minor">
+            <a:schemeClr val="lt1"/>
+          </a:fontRef>
+        </p:style>
+        <p:txBody>
+          <a:bodyPr rtlCol="0" anchor="ctr"/>
+          <a:lstStyle/>
+          <a:p>
+            <a:pPr algn="ctr"/>
+          </a:p>
+        </p:txBody>
+      </p:sp>
+      <p:sp>
+        <p:nvSpPr>
+          <p:cNvPr id="8" name="TextBox 7"/>
+          <p:cNvSpPr txBox="1"/>
+          <p:nvPr/>
+        </p:nvSpPr>
+        <p:spPr>
+          <a:xfrm>
+            <a:off x="1280160" y="2194560"/>
+            <a:ext cx="4498848" cy="2194560"/>
+          </a:xfrm>
+          <a:prstGeom prst="rect">
+            <a:avLst/>
+          </a:prstGeom>
+          <a:noFill/>
+        </p:spPr>
+        <p:txBody>
+          <a:bodyPr wrap="square">
+            <a:spAutoFit/>
+          </a:bodyPr>
+          <a:lstStyle/>
+          <a:p>
+            <a:pPr>
+              <a:spcAft>
+                <a:spcPts val="800"/>
+              </a:spcAft>
+              <a:defRPr sz="1200" b="1">
+                <a:solidFill>
+                  <a:srgbClr val="B91C1C"/>
+                </a:solidFill>
+                <a:latin typeface="Segoe UI"/>
+              </a:defRPr>
+            </a:pPr>
+            <a:r>
+              <a:t>❌ PARADIGMA IMPERATIF (VANILLA JS)</a:t>
+            </a:r>
+          </a:p>
+          <a:p>
+            <a:pPr>
+              <a:spcAft>
+                <a:spcPts val="400"/>
+              </a:spcAft>
+            </a:pPr>
+            <a:r>
+              <a:rPr sz="950" b="1">
+                <a:solidFill>
+                  <a:srgbClr val="000000"/>
+                </a:solidFill>
+                <a:latin typeface="Segoe UI"/>
+              </a:rPr>
+              <a:t>• Fokus pada HOW (Bagaimana):</a:t>
+            </a:r>
+            <a:r>
+              <a:rPr sz="950">
+                <a:solidFill>
+                  <a:srgbClr val="323232"/>
+                </a:solidFill>
+                <a:latin typeface="Segoe UI"/>
+              </a:rPr>
+              <a:t> Menginstruksikan langkah demi langkah manipulasi elemen DOM.</a:t>
+            </a:r>
+          </a:p>
+          <a:p>
+            <a:pPr>
+              <a:spcAft>
+                <a:spcPts val="400"/>
+              </a:spcAft>
+            </a:pPr>
+            <a:r>
+              <a:rPr sz="950" b="1">
+                <a:solidFill>
+                  <a:srgbClr val="000000"/>
+                </a:solidFill>
+                <a:latin typeface="Segoe UI"/>
+              </a:rPr>
+              <a:t>• Manual DOM querying:</a:t>
+            </a:r>
+            <a:r>
+              <a:rPr sz="950">
+                <a:solidFill>
+                  <a:srgbClr val="323232"/>
+                </a:solidFill>
+                <a:latin typeface="Segoe UI"/>
+              </a:rPr>
+              <a:t> Berulang kali memanggil getElementById, querySelector, &amp; innerHTML.</a:t>
+            </a:r>
+          </a:p>
+          <a:p>
+            <a:pPr>
+              <a:spcAft>
+                <a:spcPts val="400"/>
+              </a:spcAft>
+            </a:pPr>
+            <a:r>
+              <a:rPr sz="950" b="1">
+                <a:solidFill>
+                  <a:srgbClr val="000000"/>
+                </a:solidFill>
+                <a:latin typeface="Segoe UI"/>
+              </a:rPr>
+              <a:t>• Rawan Desinkronisasi:</a:t>
+            </a:r>
+            <a:r>
+              <a:rPr sz="950">
+                <a:solidFill>
+                  <a:srgbClr val="323232"/>
+                </a:solidFill>
+                <a:latin typeface="Segoe UI"/>
+              </a:rPr>
+              <a:t> Status variabel di memori sering tidak sinkron dengan tampilan layar.</a:t>
+            </a:r>
+          </a:p>
+          <a:p>
+            <a:pPr>
+              <a:spcAft>
+                <a:spcPts val="400"/>
+              </a:spcAft>
+            </a:pPr>
+            <a:r>
+              <a:rPr sz="950" b="1">
+                <a:solidFill>
+                  <a:srgbClr val="000000"/>
+                </a:solidFill>
+                <a:latin typeface="Segoe UI"/>
+              </a:rPr>
+              <a:t>• Spaghetti Code:</a:t>
+            </a:r>
+            <a:r>
+              <a:rPr sz="950">
+                <a:solidFill>
+                  <a:srgbClr val="323232"/>
+                </a:solidFill>
+                <a:latin typeface="Segoe UI"/>
+              </a:rPr>
+              <a:t> Semakin besar aplikasi, kode semakin rumit dan sulit dirawat.</a:t>
+            </a:r>
+          </a:p>
+        </p:txBody>
+      </p:sp>
+      <p:sp>
+        <p:nvSpPr>
+          <p:cNvPr id="9" name="Rectangle 8"/>
+          <p:cNvSpPr/>
+          <p:nvPr/>
+        </p:nvSpPr>
+        <p:spPr>
+          <a:xfrm>
+            <a:off x="6300216" y="2130552"/>
+            <a:ext cx="4864608" cy="2468880"/>
+          </a:xfrm>
+          <a:prstGeom prst="rect">
+            <a:avLst/>
+          </a:prstGeom>
+          <a:solidFill>
+            <a:srgbClr val="000000"/>
+          </a:solidFill>
+          <a:ln>
+            <a:noFill/>
+          </a:ln>
+        </p:spPr>
+        <p:style>
+          <a:lnRef idx="1">
+            <a:schemeClr val="accent1"/>
+          </a:lnRef>
+          <a:fillRef idx="3">
+            <a:schemeClr val="accent1"/>
+          </a:fillRef>
+          <a:effectRef idx="2">
+            <a:schemeClr val="accent1"/>
+          </a:effectRef>
+          <a:fontRef idx="minor">
+            <a:schemeClr val="lt1"/>
+          </a:fontRef>
+        </p:style>
+        <p:txBody>
+          <a:bodyPr rtlCol="0" anchor="ctr"/>
+          <a:lstStyle/>
+          <a:p>
+            <a:pPr algn="ctr"/>
+          </a:p>
+        </p:txBody>
+      </p:sp>
+      <p:sp>
+        <p:nvSpPr>
+          <p:cNvPr id="10" name="Rectangle 9"/>
+          <p:cNvSpPr/>
+          <p:nvPr/>
+        </p:nvSpPr>
+        <p:spPr>
+          <a:xfrm>
+            <a:off x="6227064" y="2057400"/>
+            <a:ext cx="4864608" cy="2468880"/>
+          </a:xfrm>
+          <a:prstGeom prst="rect">
+            <a:avLst/>
+          </a:prstGeom>
+          <a:solidFill>
+            <a:srgbClr val="4ADE80"/>
+          </a:solidFill>
+          <a:ln w="31750">
+            <a:solidFill>
+              <a:srgbClr val="000000"/>
+            </a:solidFill>
+          </a:ln>
+        </p:spPr>
+        <p:style>
+          <a:lnRef idx="1">
+            <a:schemeClr val="accent1"/>
+          </a:lnRef>
+          <a:fillRef idx="3">
+            <a:schemeClr val="accent1"/>
+          </a:fillRef>
+          <a:effectRef idx="2">
+            <a:schemeClr val="accent1"/>
+          </a:effectRef>
+          <a:fontRef idx="minor">
+            <a:schemeClr val="lt1"/>
+          </a:fontRef>
+        </p:style>
+        <p:txBody>
+          <a:bodyPr rtlCol="0" anchor="ctr"/>
+          <a:lstStyle/>
+          <a:p>
+            <a:pPr algn="ctr"/>
+          </a:p>
+        </p:txBody>
+      </p:sp>
+      <p:sp>
+        <p:nvSpPr>
+          <p:cNvPr id="11" name="TextBox 10"/>
+          <p:cNvSpPr txBox="1"/>
+          <p:nvPr/>
+        </p:nvSpPr>
+        <p:spPr>
+          <a:xfrm>
+            <a:off x="6409944" y="2194560"/>
+            <a:ext cx="4498848" cy="2194560"/>
+          </a:xfrm>
+          <a:prstGeom prst="rect">
+            <a:avLst/>
+          </a:prstGeom>
+          <a:noFill/>
+        </p:spPr>
+        <p:txBody>
+          <a:bodyPr wrap="square">
+            <a:spAutoFit/>
+          </a:bodyPr>
+          <a:lstStyle/>
+          <a:p>
+            <a:pPr>
+              <a:spcAft>
+                <a:spcPts val="800"/>
+              </a:spcAft>
+              <a:defRPr sz="1200" b="1">
+                <a:solidFill>
+                  <a:srgbClr val="15803D"/>
+                </a:solidFill>
+                <a:latin typeface="Segoe UI"/>
+              </a:defRPr>
+            </a:pPr>
+            <a:r>
+              <a:t>✅ PARADIGMA DEKLARATIF (VUE.JS 3)</a:t>
+            </a:r>
+          </a:p>
+          <a:p>
+            <a:pPr>
+              <a:spcAft>
+                <a:spcPts val="400"/>
+              </a:spcAft>
+            </a:pPr>
+            <a:r>
+              <a:rPr sz="950" b="1">
+                <a:solidFill>
+                  <a:srgbClr val="000000"/>
+                </a:solidFill>
+                <a:latin typeface="Segoe UI"/>
+              </a:rPr>
+              <a:t>• Fokus pada WHAT (Apa):</a:t>
+            </a:r>
+            <a:r>
+              <a:rPr sz="950">
+                <a:solidFill>
+                  <a:srgbClr val="323232"/>
+                </a:solidFill>
+                <a:latin typeface="Segoe UI"/>
+              </a:rPr>
+              <a:t> Mendeklarasikan data dan template; Vue mengurus sinkronisasi DOM.</a:t>
+            </a:r>
+          </a:p>
+          <a:p>
+            <a:pPr>
+              <a:spcAft>
+                <a:spcPts val="400"/>
+              </a:spcAft>
+            </a:pPr>
+            <a:r>
+              <a:rPr sz="950" b="1">
+                <a:solidFill>
+                  <a:srgbClr val="000000"/>
+                </a:solidFill>
+                <a:latin typeface="Segoe UI"/>
+              </a:rPr>
+              <a:t>• Reaktivitas Otomatis:</a:t>
+            </a:r>
+            <a:r>
+              <a:rPr sz="950">
+                <a:solidFill>
+                  <a:srgbClr val="323232"/>
+                </a:solidFill>
+                <a:latin typeface="Segoe UI"/>
+              </a:rPr>
+              <a:t> Mengubah nilai state di JavaScript langsung memutakhirkan tampilan.</a:t>
+            </a:r>
+          </a:p>
+          <a:p>
+            <a:pPr>
+              <a:spcAft>
+                <a:spcPts val="400"/>
+              </a:spcAft>
+            </a:pPr>
+            <a:r>
+              <a:rPr sz="950" b="1">
+                <a:solidFill>
+                  <a:srgbClr val="000000"/>
+                </a:solidFill>
+                <a:latin typeface="Segoe UI"/>
+              </a:rPr>
+              <a:t>• Virtual DOM Diffing:</a:t>
+            </a:r>
+            <a:r>
+              <a:rPr sz="950">
+                <a:solidFill>
+                  <a:srgbClr val="323232"/>
+                </a:solidFill>
+                <a:latin typeface="Segoe UI"/>
+              </a:rPr>
+              <a:t> Hanya node yang nilainya berubah yang di-render ulang (efisien &amp; cepat).</a:t>
+            </a:r>
+          </a:p>
+          <a:p>
+            <a:pPr>
+              <a:spcAft>
+                <a:spcPts val="400"/>
+              </a:spcAft>
+            </a:pPr>
+            <a:r>
+              <a:rPr sz="950" b="1">
+                <a:solidFill>
+                  <a:srgbClr val="000000"/>
+                </a:solidFill>
+                <a:latin typeface="Segoe UI"/>
+              </a:rPr>
+              <a:t>• Komponen Modular:</a:t>
+            </a:r>
+            <a:r>
+              <a:rPr sz="950">
+                <a:solidFill>
+                  <a:srgbClr val="323232"/>
+                </a:solidFill>
+                <a:latin typeface="Segoe UI"/>
+              </a:rPr>
+              <a:t> Kode terstruktur rapi, terisolasi, dan mudah diuji (unit-testable).</a:t>
+            </a:r>
+          </a:p>
+        </p:txBody>
+      </p:sp>
+      <p:sp>
+        <p:nvSpPr>
+          <p:cNvPr id="12" name="TextBox 11"/>
+          <p:cNvSpPr txBox="1"/>
+          <p:nvPr/>
+        </p:nvSpPr>
+        <p:spPr>
+          <a:xfrm>
+            <a:off x="1097280" y="4645152"/>
+            <a:ext cx="9997135" cy="320040"/>
+          </a:xfrm>
+          <a:prstGeom prst="rect">
+            <a:avLst/>
+          </a:prstGeom>
+          <a:noFill/>
+        </p:spPr>
+        <p:txBody>
+          <a:bodyPr wrap="none">
+            <a:spAutoFit/>
+          </a:bodyPr>
+          <a:lstStyle/>
+          <a:p>
+            <a:pPr>
+              <a:defRPr sz="1000" b="1">
+                <a:solidFill>
+                  <a:srgbClr val="000000"/>
+                </a:solidFill>
+                <a:latin typeface="Segoe UI"/>
+              </a:defRPr>
+            </a:pPr>
+            <a:r>
+              <a:t>■  Anton Prafanto, S.Kom., M.T.  ■  FAKULTAS SAINS DAN TEKNOLOGI • UNIVERSITAS TERBUKA</a:t>
+            </a:r>
+          </a:p>
+        </p:txBody>
+      </p:sp>
+      <p:sp>
+        <p:nvSpPr>
+          <p:cNvPr id="13" name="Rectangle 12"/>
+          <p:cNvSpPr/>
+          <p:nvPr/>
+        </p:nvSpPr>
+        <p:spPr>
+          <a:xfrm>
+            <a:off x="1133856" y="5065776"/>
+            <a:ext cx="9997135" cy="640080"/>
+          </a:xfrm>
+          <a:prstGeom prst="rect">
+            <a:avLst/>
+          </a:prstGeom>
+          <a:solidFill>
+            <a:srgbClr val="000000"/>
+          </a:solidFill>
+          <a:ln>
+            <a:noFill/>
+          </a:ln>
+        </p:spPr>
+        <p:style>
+          <a:lnRef idx="1">
+            <a:schemeClr val="accent1"/>
+          </a:lnRef>
+          <a:fillRef idx="3">
+            <a:schemeClr val="accent1"/>
+          </a:fillRef>
+          <a:effectRef idx="2">
+            <a:schemeClr val="accent1"/>
+          </a:effectRef>
+          <a:fontRef idx="minor">
+            <a:schemeClr val="lt1"/>
+          </a:fontRef>
+        </p:style>
+        <p:txBody>
+          <a:bodyPr rtlCol="0" anchor="ctr"/>
+          <a:lstStyle/>
+          <a:p>
+            <a:pPr algn="ctr"/>
+          </a:p>
+        </p:txBody>
+      </p:sp>
+      <p:sp>
+        <p:nvSpPr>
+          <p:cNvPr id="14" name="Rectangle 13">
             <a:hlinkClick r:id="rId2"/>
           </p:cNvPr>
           <p:cNvSpPr/>
@@ -3377,8 +3851,8 @@
         </p:nvSpPr>
         <p:spPr>
           <a:xfrm>
-            <a:off x="1280160" y="5074920"/>
-            <a:ext cx="9601200" cy="621792"/>
+            <a:off x="1097280" y="5029200"/>
+            <a:ext cx="9997135" cy="640080"/>
           </a:xfrm>
           <a:prstGeom prst="rect">
             <a:avLst/>
@@ -3416,14 +3890,14 @@
       </p:sp>
       <p:sp>
         <p:nvSpPr>
-          <p:cNvPr id="8" name="TextBox 7"/>
+          <p:cNvPr id="15" name="TextBox 14"/>
           <p:cNvSpPr txBox="1"/>
           <p:nvPr/>
         </p:nvSpPr>
         <p:spPr>
           <a:xfrm>
-            <a:off x="1371600" y="5111496"/>
-            <a:ext cx="9418320" cy="548640"/>
+            <a:off x="1188720" y="5065776"/>
+            <a:ext cx="9814255" cy="566928"/>
           </a:xfrm>
           <a:prstGeom prst="rect">
             <a:avLst/>

</xml_diff>